<commit_message>
Add the single-file HTML dashboard, team contributions and the SoICT logo
- HTML dashboard: the Streamlit dashboard's three pages in one file built
  by export, with an in-browser engine checked against the Python engine
  (Node parity tests) and a Chrome check (scripts/html_dashboard_qa.py).
- run_dashboard.bat starts the Streamlit dashboard and creates the
  environment on first use.
- One team list for the report cover, the report's contribution table and
  a new Team Contributions slide (17 slides).
- HUST SoICT logo on the report cover, the title slide and the slide footer.
- Second code-review round: break-even with a zero standard save rate,
  per-PDF run provenance, sources from another run refused, LaTeX passes
  that never settle, every submission file hashed and checked, read-only
  folders removed on every platform.
- scripts/build_submission.py builds the Group_1 submission folder.
- Results regenerated from two final runs; verification record updated.
</commit_message>
<xml_diff>
--- a/reports/presentation/retention-presentation.pptx
+++ b/reports/presentation/retention-presentation.pptx
@@ -28,6 +28,7 @@
     <p:sldId id="269" r:id="rId18"/>
     <p:sldId id="270" r:id="rId17"/>
     <p:sldId id="271" r:id="rId16"/>
+    <p:sldId id="272" r:id="rId15"/>
   </p:sldIdLst>
   <p:sldSz cx="12192000" cy="6858000"/>
   <p:notesSz cx="7559675" cy="10691813"/>
@@ -1335,7 +1336,7 @@
           <a:lstStyle/>
           <a:p>
             <a:r>
-              <a:t>[Dung | 6:05-7:00 | 55 s]</a:t>
+              <a:t>[Dung | 6:05-6:55 | 50 s]</a:t>
             </a:r>
           </a:p>
           <a:p>
@@ -1398,7 +1399,7 @@
           <a:lstStyle/>
           <a:p>
             <a:r>
-              <a:t>[Dung | 7:00-7:55 | 55 s]</a:t>
+              <a:t>[Dung | 6:55-7:45 | 50 s]</a:t>
             </a:r>
           </a:p>
           <a:p>
@@ -1559,6 +1560,69 @@
           <a:lstStyle/>
           <a:p>
             <a:r>
+              <a:t>[Dung | 7:45-7:55 | 10 s]</a:t>
+            </a:r>
+          </a:p>
+          <a:p>
+            <a:r>
+              <a:t>Who did what: Kiet led the project and the report, Hieu the decision engine, Phong the data and models, and I these slides.</a:t>
+            </a:r>
+          </a:p>
+        </p:txBody>
+      </p:sp>
+    </p:spTree>
+  </p:cSld>
+  <p:clrMapOvr>
+    <a:masterClrMapping/>
+  </p:clrMapOvr>
+</p:notes>
+</file>
+
+<file path=ppt/notesSlides/notesSlide16.xml><?xml version="1.0" encoding="utf-8"?>
+<p:notes xmlns:a="http://schemas.openxmlformats.org/drawingml/2006/main" xmlns:p="http://schemas.openxmlformats.org/presentationml/2006/main" xmlns:r="http://schemas.openxmlformats.org/officeDocument/2006/relationships">
+  <p:cSld>
+    <p:spTree>
+      <p:nvGrpSpPr>
+        <p:cNvPr id="1" name=""/>
+        <p:cNvGrpSpPr/>
+        <p:nvPr/>
+      </p:nvGrpSpPr>
+      <p:grpSpPr>
+        <a:xfrm>
+          <a:off x="0" y="0"/>
+          <a:ext cx="0" cy="0"/>
+          <a:chOff x="0" y="0"/>
+          <a:chExt cx="0" cy="0"/>
+        </a:xfrm>
+      </p:grpSpPr>
+      <p:sp>
+        <p:nvSpPr>
+          <p:cNvPr id="2" name="Slide Image Placeholder 1"/>
+          <p:cNvSpPr>
+            <a:spLocks noGrp="1"/>
+          </p:cNvSpPr>
+          <p:nvPr>
+            <p:ph type="sldImg" idx="2"/>
+          </p:nvPr>
+        </p:nvSpPr>
+        <p:spPr/>
+      </p:sp>
+      <p:sp>
+        <p:nvSpPr>
+          <p:cNvPr id="3" name="Notes Placeholder 2"/>
+          <p:cNvSpPr>
+            <a:spLocks noGrp="1"/>
+          </p:cNvSpPr>
+          <p:nvPr>
+            <p:ph type="body" idx="1"/>
+          </p:nvPr>
+        </p:nvSpPr>
+        <p:spPr/>
+        <p:txBody>
+          <a:bodyPr/>
+          <a:lstStyle/>
+          <a:p>
+            <a:r>
               <a:t>[Dung | 7:55-8:00 | 5 s]</a:t>
             </a:r>
           </a:p>
@@ -1577,7 +1641,7 @@
 </p:notes>
 </file>
 
-<file path=ppt/notesSlides/notesSlide16.xml><?xml version="1.0" encoding="utf-8"?>
+<file path=ppt/notesSlides/notesSlide17.xml><?xml version="1.0" encoding="utf-8"?>
 <p:notes xmlns:a="http://schemas.openxmlformats.org/drawingml/2006/main" xmlns:p="http://schemas.openxmlformats.org/presentationml/2006/main" xmlns:r="http://schemas.openxmlformats.org/officeDocument/2006/relationships">
   <p:cSld>
     <p:spTree>
@@ -38836,7 +38900,7 @@
       <p:grpSpPr/>
       <p:pic>
         <p:nvPicPr>
-          <p:cNvPr id="2" name="Picture 1" descr="hust-logo.png"/>
+          <p:cNvPr id="2" name="Picture 1" descr="soict-logo.png"/>
           <p:cNvPicPr>
             <a:picLocks noChangeAspect="1"/>
           </p:cNvPicPr>
@@ -38850,8 +38914,8 @@
         </p:blipFill>
         <p:spPr>
           <a:xfrm>
-            <a:off x="393192" y="274320"/>
-            <a:ext cx="3172968" cy="1152144"/>
+            <a:off x="457200" y="411480"/>
+            <a:ext cx="2138822" cy="868680"/>
           </a:xfrm>
           <a:prstGeom prst="rect">
             <a:avLst/>
@@ -41632,6 +41696,523 @@
         </p:nvSpPr>
         <p:spPr>
           <a:xfrm>
+            <a:off x="338328" y="109728"/>
+            <a:ext cx="11512296" cy="438912"/>
+          </a:xfrm>
+          <a:prstGeom prst="rect">
+            <a:avLst/>
+          </a:prstGeom>
+          <a:noFill/>
+        </p:spPr>
+        <p:txBody>
+          <a:bodyPr wrap="square" anchor="t">
+            <a:spAutoFit/>
+          </a:bodyPr>
+          <a:lstStyle/>
+          <a:p>
+            <a:pPr algn="l">
+              <a:spcAft>
+                <a:spcPts val="600"/>
+              </a:spcAft>
+            </a:pPr>
+            <a:r>
+              <a:rPr sz="2800" b="1" i="0">
+                <a:solidFill>
+                  <a:srgbClr val="FFFFFF"/>
+                </a:solidFill>
+                <a:latin typeface="Calibri"/>
+              </a:rPr>
+              <a:t>Team Contributions</a:t>
+            </a:r>
+          </a:p>
+        </p:txBody>
+      </p:sp>
+      <p:sp>
+        <p:nvSpPr>
+          <p:cNvPr id="3" name="TextBox 2"/>
+          <p:cNvSpPr txBox="1"/>
+          <p:nvPr/>
+        </p:nvSpPr>
+        <p:spPr>
+          <a:xfrm>
+            <a:off x="11045952" y="6473952"/>
+            <a:ext cx="822960" cy="301752"/>
+          </a:xfrm>
+          <a:prstGeom prst="rect">
+            <a:avLst/>
+          </a:prstGeom>
+          <a:noFill/>
+        </p:spPr>
+        <p:txBody>
+          <a:bodyPr wrap="square" anchor="t">
+            <a:spAutoFit/>
+          </a:bodyPr>
+          <a:lstStyle/>
+          <a:p>
+            <a:pPr algn="r">
+              <a:spcAft>
+                <a:spcPts val="600"/>
+              </a:spcAft>
+            </a:pPr>
+            <a:r>
+              <a:rPr sz="1100" b="0" i="0">
+                <a:solidFill>
+                  <a:srgbClr val="6B7280"/>
+                </a:solidFill>
+                <a:latin typeface="Calibri"/>
+              </a:rPr>
+              <a:t>15</a:t>
+            </a:r>
+          </a:p>
+        </p:txBody>
+      </p:sp>
+      <p:graphicFrame>
+        <p:nvGraphicFramePr>
+          <p:cNvPr id="4" name="Table 3"/>
+          <p:cNvGraphicFramePr>
+            <a:graphicFrameLocks noGrp="1"/>
+          </p:cNvGraphicFramePr>
+          <p:nvPr/>
+        </p:nvGraphicFramePr>
+        <p:xfrm>
+          <a:off x="457200" y="1325880"/>
+          <a:ext cx="11292840" cy="4343400"/>
+        </p:xfrm>
+        <a:graphic>
+          <a:graphicData uri="http://schemas.openxmlformats.org/drawingml/2006/table">
+            <a:tbl>
+              <a:tblPr firstRow="1" bandRow="1">
+                <a:tableStyleId>{5C22544A-7EE6-4342-B048-85BDC9FD1C3A}</a:tableStyleId>
+              </a:tblPr>
+              <a:tblGrid>
+                <a:gridCol w="2651760"/>
+                <a:gridCol w="1600200"/>
+                <a:gridCol w="7040880"/>
+              </a:tblGrid>
+              <a:tr h="868680">
+                <a:tc>
+                  <a:txBody>
+                    <a:bodyPr wrap="square"/>
+                    <a:lstStyle/>
+                    <a:p>
+                      <a:pPr algn="l"/>
+                      <a:r>
+                        <a:rPr sz="1600" b="1" i="0">
+                          <a:solidFill>
+                            <a:srgbClr val="FFFFFF"/>
+                          </a:solidFill>
+                          <a:latin typeface="Calibri"/>
+                        </a:rPr>
+                        <a:t>Member</a:t>
+                      </a:r>
+                    </a:p>
+                  </a:txBody>
+                  <a:tcPr marL="91440" marR="91440" marT="27432" marB="27432" anchor="ctr">
+                    <a:solidFill>
+                      <a:srgbClr val="0B2E63"/>
+                    </a:solidFill>
+                  </a:tcPr>
+                </a:tc>
+                <a:tc>
+                  <a:txBody>
+                    <a:bodyPr wrap="square"/>
+                    <a:lstStyle/>
+                    <a:p>
+                      <a:pPr algn="l"/>
+                      <a:r>
+                        <a:rPr sz="1600" b="1" i="0">
+                          <a:solidFill>
+                            <a:srgbClr val="FFFFFF"/>
+                          </a:solidFill>
+                          <a:latin typeface="Calibri"/>
+                        </a:rPr>
+                        <a:t>Student ID</a:t>
+                      </a:r>
+                    </a:p>
+                  </a:txBody>
+                  <a:tcPr marL="91440" marR="91440" marT="27432" marB="27432" anchor="ctr">
+                    <a:solidFill>
+                      <a:srgbClr val="0B2E63"/>
+                    </a:solidFill>
+                  </a:tcPr>
+                </a:tc>
+                <a:tc>
+                  <a:txBody>
+                    <a:bodyPr wrap="square"/>
+                    <a:lstStyle/>
+                    <a:p>
+                      <a:pPr algn="l"/>
+                      <a:r>
+                        <a:rPr sz="1600" b="1" i="0">
+                          <a:solidFill>
+                            <a:srgbClr val="FFFFFF"/>
+                          </a:solidFill>
+                          <a:latin typeface="Calibri"/>
+                        </a:rPr>
+                        <a:t>Main contributions</a:t>
+                      </a:r>
+                    </a:p>
+                  </a:txBody>
+                  <a:tcPr marL="91440" marR="91440" marT="27432" marB="27432" anchor="ctr">
+                    <a:solidFill>
+                      <a:srgbClr val="0B2E63"/>
+                    </a:solidFill>
+                  </a:tcPr>
+                </a:tc>
+              </a:tr>
+              <a:tr h="868680">
+                <a:tc>
+                  <a:txBody>
+                    <a:bodyPr wrap="square"/>
+                    <a:lstStyle/>
+                    <a:p>
+                      <a:pPr algn="l"/>
+                      <a:r>
+                        <a:rPr sz="1500" b="0" i="0">
+                          <a:solidFill>
+                            <a:srgbClr val="1F2937"/>
+                          </a:solidFill>
+                          <a:latin typeface="Calibri"/>
+                        </a:rPr>
+                        <a:t>Pham Tuan Kiet</a:t>
+                      </a:r>
+                    </a:p>
+                  </a:txBody>
+                  <a:tcPr marL="91440" marR="91440" marT="27432" marB="27432" anchor="ctr">
+                    <a:solidFill>
+                      <a:srgbClr val="EEF2F8"/>
+                    </a:solidFill>
+                  </a:tcPr>
+                </a:tc>
+                <a:tc>
+                  <a:txBody>
+                    <a:bodyPr wrap="square"/>
+                    <a:lstStyle/>
+                    <a:p>
+                      <a:pPr algn="l"/>
+                      <a:r>
+                        <a:rPr sz="1500" b="0" i="0">
+                          <a:solidFill>
+                            <a:srgbClr val="1F2937"/>
+                          </a:solidFill>
+                          <a:latin typeface="Calibri"/>
+                        </a:rPr>
+                        <a:t>20252751M</a:t>
+                      </a:r>
+                    </a:p>
+                  </a:txBody>
+                  <a:tcPr marL="91440" marR="91440" marT="27432" marB="27432" anchor="ctr">
+                    <a:solidFill>
+                      <a:srgbClr val="EEF2F8"/>
+                    </a:solidFill>
+                  </a:tcPr>
+                </a:tc>
+                <a:tc>
+                  <a:txBody>
+                    <a:bodyPr wrap="square"/>
+                    <a:lstStyle/>
+                    <a:p>
+                      <a:pPr algn="l"/>
+                      <a:r>
+                        <a:rPr sz="1500" b="0" i="0">
+                          <a:solidFill>
+                            <a:srgbClr val="1F2937"/>
+                          </a:solidFill>
+                          <a:latin typeface="Calibri"/>
+                        </a:rPr>
+                        <a:t>Project management; code review and improvements (pilot and stress-test fixes, report generation, single-file HTML dashboard); reproducibility check; final report</a:t>
+                      </a:r>
+                    </a:p>
+                  </a:txBody>
+                  <a:tcPr marL="91440" marR="91440" marT="27432" marB="27432" anchor="ctr">
+                    <a:solidFill>
+                      <a:srgbClr val="EEF2F8"/>
+                    </a:solidFill>
+                  </a:tcPr>
+                </a:tc>
+              </a:tr>
+              <a:tr h="868680">
+                <a:tc>
+                  <a:txBody>
+                    <a:bodyPr wrap="square"/>
+                    <a:lstStyle/>
+                    <a:p>
+                      <a:pPr algn="l"/>
+                      <a:r>
+                        <a:rPr sz="1500" b="0" i="0">
+                          <a:solidFill>
+                            <a:srgbClr val="1F2937"/>
+                          </a:solidFill>
+                          <a:latin typeface="Calibri"/>
+                        </a:rPr>
+                        <a:t>Nguyen Trung Hieu</a:t>
+                      </a:r>
+                    </a:p>
+                  </a:txBody>
+                  <a:tcPr marL="91440" marR="91440" marT="27432" marB="27432" anchor="ctr">
+                    <a:solidFill>
+                      <a:srgbClr val="FFFFFF"/>
+                    </a:solidFill>
+                  </a:tcPr>
+                </a:tc>
+                <a:tc>
+                  <a:txBody>
+                    <a:bodyPr wrap="square"/>
+                    <a:lstStyle/>
+                    <a:p>
+                      <a:pPr algn="l"/>
+                      <a:r>
+                        <a:rPr sz="1500" b="0" i="0">
+                          <a:solidFill>
+                            <a:srgbClr val="1F2937"/>
+                          </a:solidFill>
+                          <a:latin typeface="Calibri"/>
+                        </a:rPr>
+                        <a:t>20261059M</a:t>
+                      </a:r>
+                    </a:p>
+                  </a:txBody>
+                  <a:tcPr marL="91440" marR="91440" marT="27432" marB="27432" anchor="ctr">
+                    <a:solidFill>
+                      <a:srgbClr val="FFFFFF"/>
+                    </a:solidFill>
+                  </a:tcPr>
+                </a:tc>
+                <a:tc>
+                  <a:txBody>
+                    <a:bodyPr wrap="square"/>
+                    <a:lstStyle/>
+                    <a:p>
+                      <a:pPr algn="l"/>
+                      <a:r>
+                        <a:rPr sz="1500" b="0" i="0">
+                          <a:solidFill>
+                            <a:srgbClr val="1F2937"/>
+                          </a:solidFill>
+                          <a:latin typeface="Calibri"/>
+                        </a:rPr>
+                        <a:t>Decision engine, robustness and Monte Carlo analysis, dashboard redesign, business documents</a:t>
+                      </a:r>
+                    </a:p>
+                  </a:txBody>
+                  <a:tcPr marL="91440" marR="91440" marT="27432" marB="27432" anchor="ctr">
+                    <a:solidFill>
+                      <a:srgbClr val="FFFFFF"/>
+                    </a:solidFill>
+                  </a:tcPr>
+                </a:tc>
+              </a:tr>
+              <a:tr h="868680">
+                <a:tc>
+                  <a:txBody>
+                    <a:bodyPr wrap="square"/>
+                    <a:lstStyle/>
+                    <a:p>
+                      <a:pPr algn="l"/>
+                      <a:r>
+                        <a:rPr sz="1500" b="0" i="0">
+                          <a:solidFill>
+                            <a:srgbClr val="1F2937"/>
+                          </a:solidFill>
+                          <a:latin typeface="Calibri"/>
+                        </a:rPr>
+                        <a:t>Bui Tien Dung</a:t>
+                      </a:r>
+                    </a:p>
+                  </a:txBody>
+                  <a:tcPr marL="91440" marR="91440" marT="27432" marB="27432" anchor="ctr">
+                    <a:solidFill>
+                      <a:srgbClr val="EEF2F8"/>
+                    </a:solidFill>
+                  </a:tcPr>
+                </a:tc>
+                <a:tc>
+                  <a:txBody>
+                    <a:bodyPr wrap="square"/>
+                    <a:lstStyle/>
+                    <a:p>
+                      <a:pPr algn="l"/>
+                      <a:r>
+                        <a:rPr sz="1500" b="0" i="0">
+                          <a:solidFill>
+                            <a:srgbClr val="1F2937"/>
+                          </a:solidFill>
+                          <a:latin typeface="Calibri"/>
+                        </a:rPr>
+                        <a:t>20261204M</a:t>
+                      </a:r>
+                    </a:p>
+                  </a:txBody>
+                  <a:tcPr marL="91440" marR="91440" marT="27432" marB="27432" anchor="ctr">
+                    <a:solidFill>
+                      <a:srgbClr val="EEF2F8"/>
+                    </a:solidFill>
+                  </a:tcPr>
+                </a:tc>
+                <a:tc>
+                  <a:txBody>
+                    <a:bodyPr wrap="square"/>
+                    <a:lstStyle/>
+                    <a:p>
+                      <a:pPr algn="l"/>
+                      <a:r>
+                        <a:rPr sz="1500" b="0" i="0">
+                          <a:solidFill>
+                            <a:srgbClr val="1F2937"/>
+                          </a:solidFill>
+                          <a:latin typeface="Calibri"/>
+                        </a:rPr>
+                        <a:t>Presentation slides and speaker script; review and quality assurance of code and report</a:t>
+                      </a:r>
+                    </a:p>
+                  </a:txBody>
+                  <a:tcPr marL="91440" marR="91440" marT="27432" marB="27432" anchor="ctr">
+                    <a:solidFill>
+                      <a:srgbClr val="EEF2F8"/>
+                    </a:solidFill>
+                  </a:tcPr>
+                </a:tc>
+              </a:tr>
+              <a:tr h="868680">
+                <a:tc>
+                  <a:txBody>
+                    <a:bodyPr wrap="square"/>
+                    <a:lstStyle/>
+                    <a:p>
+                      <a:pPr algn="l"/>
+                      <a:r>
+                        <a:rPr sz="1500" b="0" i="0">
+                          <a:solidFill>
+                            <a:srgbClr val="1F2937"/>
+                          </a:solidFill>
+                          <a:latin typeface="Calibri"/>
+                        </a:rPr>
+                        <a:t>Pham Hung Phong</a:t>
+                      </a:r>
+                    </a:p>
+                  </a:txBody>
+                  <a:tcPr marL="91440" marR="91440" marT="27432" marB="27432" anchor="ctr">
+                    <a:solidFill>
+                      <a:srgbClr val="FFFFFF"/>
+                    </a:solidFill>
+                  </a:tcPr>
+                </a:tc>
+                <a:tc>
+                  <a:txBody>
+                    <a:bodyPr wrap="square"/>
+                    <a:lstStyle/>
+                    <a:p>
+                      <a:pPr algn="l"/>
+                      <a:r>
+                        <a:rPr sz="1500" b="0" i="0">
+                          <a:solidFill>
+                            <a:srgbClr val="1F2937"/>
+                          </a:solidFill>
+                          <a:latin typeface="Calibri"/>
+                        </a:rPr>
+                        <a:t>20261061M</a:t>
+                      </a:r>
+                    </a:p>
+                  </a:txBody>
+                  <a:tcPr marL="91440" marR="91440" marT="27432" marB="27432" anchor="ctr">
+                    <a:solidFill>
+                      <a:srgbClr val="FFFFFF"/>
+                    </a:solidFill>
+                  </a:tcPr>
+                </a:tc>
+                <a:tc>
+                  <a:txBody>
+                    <a:bodyPr wrap="square"/>
+                    <a:lstStyle/>
+                    <a:p>
+                      <a:pPr algn="l"/>
+                      <a:r>
+                        <a:rPr sz="1500" b="0" i="0">
+                          <a:solidFill>
+                            <a:srgbClr val="1F2937"/>
+                          </a:solidFill>
+                          <a:latin typeface="Calibri"/>
+                        </a:rPr>
+                        <a:t>Data pipeline, churn models and first version of the dashboard</a:t>
+                      </a:r>
+                    </a:p>
+                  </a:txBody>
+                  <a:tcPr marL="91440" marR="91440" marT="27432" marB="27432" anchor="ctr">
+                    <a:solidFill>
+                      <a:srgbClr val="FFFFFF"/>
+                    </a:solidFill>
+                  </a:tcPr>
+                </a:tc>
+              </a:tr>
+            </a:tbl>
+          </a:graphicData>
+        </a:graphic>
+      </p:graphicFrame>
+      <p:sp>
+        <p:nvSpPr>
+          <p:cNvPr id="5" name="TextBox 4"/>
+          <p:cNvSpPr txBox="1"/>
+          <p:nvPr/>
+        </p:nvSpPr>
+        <p:spPr>
+          <a:xfrm>
+            <a:off x="457200" y="5852160"/>
+            <a:ext cx="11292840" cy="320040"/>
+          </a:xfrm>
+          <a:prstGeom prst="rect">
+            <a:avLst/>
+          </a:prstGeom>
+          <a:noFill/>
+        </p:spPr>
+        <p:txBody>
+          <a:bodyPr wrap="square" anchor="t">
+            <a:spAutoFit/>
+          </a:bodyPr>
+          <a:lstStyle/>
+          <a:p>
+            <a:pPr algn="l">
+              <a:spcAft>
+                <a:spcPts val="600"/>
+              </a:spcAft>
+            </a:pPr>
+            <a:r>
+              <a:rPr sz="1200" b="0" i="0">
+                <a:solidFill>
+                  <a:srgbClr val="6B7280"/>
+                </a:solidFill>
+                <a:latin typeface="Calibri"/>
+              </a:rPr>
+              <a:t>Phong runs the live demo; Kiet, Hieu and Dung give the talk. The same table is in the final report.</a:t>
+            </a:r>
+          </a:p>
+        </p:txBody>
+      </p:sp>
+    </p:spTree>
+  </p:cSld>
+  <p:clrMapOvr>
+    <a:masterClrMapping/>
+  </p:clrMapOvr>
+</p:sld>
+</file>
+
+<file path=ppt/slides/slide16.xml><?xml version="1.0" encoding="utf-8"?>
+<p:sld xmlns:a="http://schemas.openxmlformats.org/drawingml/2006/main" xmlns:p="http://schemas.openxmlformats.org/presentationml/2006/main" xmlns:r="http://schemas.openxmlformats.org/officeDocument/2006/relationships">
+  <p:cSld>
+    <p:spTree>
+      <p:nvGrpSpPr>
+        <p:cNvPr id="1" name=""/>
+        <p:cNvGrpSpPr/>
+        <p:nvPr/>
+      </p:nvGrpSpPr>
+      <p:grpSpPr/>
+      <p:sp>
+        <p:nvSpPr>
+          <p:cNvPr id="2" name="TextBox 1"/>
+          <p:cNvSpPr txBox="1"/>
+          <p:nvPr/>
+        </p:nvSpPr>
+        <p:spPr>
+          <a:xfrm>
             <a:off x="5760720" y="2743200"/>
             <a:ext cx="6035040" cy="1005840"/>
           </a:xfrm>
@@ -41710,7 +42291,7 @@
 </p:sld>
 </file>
 
-<file path=ppt/slides/slide16.xml><?xml version="1.0" encoding="utf-8"?>
+<file path=ppt/slides/slide17.xml><?xml version="1.0" encoding="utf-8"?>
 <p:sld xmlns:a="http://schemas.openxmlformats.org/drawingml/2006/main" xmlns:p="http://schemas.openxmlformats.org/presentationml/2006/main" xmlns:r="http://schemas.openxmlformats.org/officeDocument/2006/relationships">
   <p:cSld>
     <p:spTree>

</xml_diff>

<commit_message>
Phong gives the opening of the talk and Kiet runs the demo
- Speaker script: Phong presents slides 1-5 and Kiet runs the live
  dashboard demo; timings unchanged (8:00, 2:40 each).
- Dung's contribution: presentation slides and executive brief.
- Results regenerated from two final runs; verification record updated.
</commit_message>
<xml_diff>
--- a/reports/presentation/retention-presentation.pptx
+++ b/reports/presentation/retention-presentation.pptx
@@ -1147,12 +1147,12 @@
           <a:lstStyle/>
           <a:p>
             <a:r>
-              <a:t>[Kiet | 0:00-0:15 | 15 s]</a:t>
+              <a:t>[Phong | 0:00-0:15 | 15 s]</a:t>
             </a:r>
           </a:p>
           <a:p>
             <a:r>
-              <a:t>Good morning, Professor, and everyone. We are Group 1, presenting Topic 7: profit-aware telecom churn and retention targeting. Hieu, Dung and I will present, and Phong will demo our dashboard at the end.</a:t>
+              <a:t>Good morning, Professor, and everyone. We are Group 1, presenting Topic 7: profit-aware telecom churn and retention targeting. Hieu, Dung and I will present, and Kiet will demo our dashboard at the end.</a:t>
             </a:r>
           </a:p>
         </p:txBody>
@@ -1404,7 +1404,7 @@
           </a:p>
           <a:p>
             <a:r>
-              <a:t>So our recommendation to the Head of Retention is to adopt expected-value targeting with segment offers, but to launch it as a randomised pilot. One wave of 1,620 customers from the recommended list is split at random: half receive the offer, half are held out. After 90 days we measure the real save rate of this offer mix, which we assume to be 22.6%. The decision rule is agreed now: go if the effect is significant and at least the break-even of 15.6%; stop if it is clearly below. The offered half costs about $22,875, and if our assumption holds, the rule says go 97% of the time. A decision is ready about 19 weeks after approval. Phong will now show our dashboard.</a:t>
+              <a:t>So our recommendation to the Head of Retention is to adopt expected-value targeting with segment offers, but to launch it as a randomised pilot. One wave of 1,620 customers from the recommended list is split at random: half receive the offer, half are held out. After 90 days we measure the real save rate of this offer mix, which we assume to be 22.6%. The decision rule is agreed now: go if the effect is significant and at least the break-even of 15.6%; stop if it is clearly below. The offered half costs about $22,875, and if our assumption holds, the rule says go 97% of the time. A decision is ready about 19 weeks after approval. Kiet will now show our dashboard.</a:t>
             </a:r>
           </a:p>
         </p:txBody>
@@ -1462,7 +1462,7 @@
           <a:lstStyle/>
           <a:p>
             <a:r>
-              <a:t>[Phong | live demo before the closing words, not part of the 8-minute talk | full timed steps in demo-script.md]</a:t>
+              <a:t>[Kiet | live demo before the closing words, not part of the 8-minute talk | full timed steps in demo-script.md]</a:t>
             </a:r>
           </a:p>
           <a:p>
@@ -1749,7 +1749,7 @@
           <a:lstStyle/>
           <a:p>
             <a:r>
-              <a:t>[Kiet | 0:15-0:25 | 10 s]</a:t>
+              <a:t>[Phong | 0:15-0:25 | 10 s]</a:t>
             </a:r>
           </a:p>
           <a:p>
@@ -1812,7 +1812,7 @@
           <a:lstStyle/>
           <a:p>
             <a:r>
-              <a:t>[Kiet | 0:25-1:15 | 50 s]</a:t>
+              <a:t>[Phong | 0:25-1:15 | 50 s]</a:t>
             </a:r>
           </a:p>
           <a:p>
@@ -1875,7 +1875,7 @@
           <a:lstStyle/>
           <a:p>
             <a:r>
-              <a:t>[Kiet | 1:15-2:00 | 45 s]</a:t>
+              <a:t>[Phong | 1:15-2:00 | 45 s]</a:t>
             </a:r>
           </a:p>
           <a:p>
@@ -1938,7 +1938,7 @@
           <a:lstStyle/>
           <a:p>
             <a:r>
-              <a:t>[Kiet | 2:00-2:40 | 40 s]</a:t>
+              <a:t>[Phong | 2:00-2:40 | 40 s]</a:t>
             </a:r>
           </a:p>
           <a:p>
@@ -2006,7 +2006,7 @@
           </a:p>
           <a:p>
             <a:r>
-              <a:t>Thank you, Kiet. I will start with the churn model.</a:t>
+              <a:t>Thank you, Phong. I will start with the churn model.</a:t>
             </a:r>
           </a:p>
         </p:txBody>
@@ -42062,7 +42062,7 @@
                           </a:solidFill>
                           <a:latin typeface="Calibri"/>
                         </a:rPr>
-                        <a:t>Presentation slides and speaker script; review and quality assurance of code and report</a:t>
+                        <a:t>Presentation slides and executive brief; review and quality assurance of code and report</a:t>
                       </a:r>
                     </a:p>
                   </a:txBody>
@@ -42182,7 +42182,7 @@
                 </a:solidFill>
                 <a:latin typeface="Calibri"/>
               </a:rPr>
-              <a:t>Phong runs the live demo; Kiet, Hieu and Dung give the talk. The same table is in the final report.</a:t>
+              <a:t>Kiet runs the live demo; Phong, Hieu and Dung give the talk. The same table is in the final report.</a:t>
             </a:r>
           </a:p>
         </p:txBody>

</xml_diff>